<commit_message>
refactor: migrate Week 4 scripts and plots to dedicated folder and clean up Week 3 lab files
</commit_message>
<xml_diff>
--- a/Assignment/Week3/Slide/slides_Week3.pptx
+++ b/Assignment/Week3/Slide/slides_Week3.pptx
@@ -4682,7 +4682,7 @@
         </p:nvGraphicFramePr>
         <p:xfrm>
           <a:off x="566928" y="1444752"/>
-          <a:ext cx="11045952" cy="2267712"/>
+          <a:ext cx="11045951" cy="2542032"/>
         </p:xfrm>
         <a:graphic>
           <a:graphicData uri="http://schemas.openxmlformats.org/drawingml/2006/table">
@@ -4691,20 +4691,21 @@
                 <a:tableStyleId>{5C22544A-7EE6-4342-B048-85BDC9FD1C3A}</a:tableStyleId>
               </a:tblPr>
               <a:tblGrid>
-                <a:gridCol w="3246120"/>
-                <a:gridCol w="2560320"/>
-                <a:gridCol w="2743200"/>
+                <a:gridCol w="2514600"/>
+                <a:gridCol w="1874519"/>
+                <a:gridCol w="1920240"/>
+                <a:gridCol w="2240280"/>
                 <a:gridCol w="2496312"/>
               </a:tblGrid>
-              <a:tr h="566928">
-                <a:tc>
+              <a:tr h="508406">
+                <a:tc rowSpan="2">
                   <a:txBody>
                     <a:bodyPr/>
                     <a:lstStyle/>
                     <a:p>
                       <a:pPr algn="l"/>
                       <a:r>
-                        <a:rPr sz="1500" b="1">
+                        <a:rPr sz="1200" b="1">
                           <a:solidFill>
                             <a:srgbClr val="FFFFFF"/>
                           </a:solidFill>
@@ -4714,9 +4715,109 @@
                       </a:r>
                     </a:p>
                   </a:txBody>
-                  <a:tcPr anchor="ctr" marL="73152" marR="73152">
+                  <a:tcPr anchor="ctr" marL="54864" marR="54864" marT="18288" marB="18288">
                     <a:solidFill>
                       <a:srgbClr val="2D6A4F"/>
+                    </a:solidFill>
+                  </a:tcPr>
+                </a:tc>
+                <a:tc gridSpan="3">
+                  <a:txBody>
+                    <a:bodyPr/>
+                    <a:lstStyle/>
+                    <a:p>
+                      <a:pPr algn="ctr"/>
+                      <a:r>
+                        <a:rPr sz="1200" b="1">
+                          <a:solidFill>
+                            <a:srgbClr val="FFFFFF"/>
+                          </a:solidFill>
+                          <a:latin typeface="Arial"/>
+                        </a:rPr>
+                        <a:t>คำนวณมือ</a:t>
+                      </a:r>
+                    </a:p>
+                  </a:txBody>
+                  <a:tcPr anchor="ctr" marL="54864" marR="54864" marT="18288" marB="18288">
+                    <a:solidFill>
+                      <a:srgbClr val="6C757D"/>
+                    </a:solidFill>
+                  </a:tcPr>
+                </a:tc>
+                <a:tc hMerge="1">
+                  <a:txBody>
+                    <a:bodyPr/>
+                    <a:lstStyle/>
+                    <a:p/>
+                  </a:txBody>
+                  <a:tcPr/>
+                </a:tc>
+                <a:tc hMerge="1">
+                  <a:txBody>
+                    <a:bodyPr/>
+                    <a:lstStyle/>
+                    <a:p/>
+                  </a:txBody>
+                  <a:tcPr/>
+                </a:tc>
+                <a:tc>
+                  <a:txBody>
+                    <a:bodyPr/>
+                    <a:lstStyle/>
+                    <a:p>
+                      <a:pPr algn="ctr"/>
+                      <a:r>
+                        <a:rPr sz="1200" b="1">
+                          <a:solidFill>
+                            <a:srgbClr val="FFFFFF"/>
+                          </a:solidFill>
+                          <a:latin typeface="Arial"/>
+                        </a:rPr>
+                        <a:t>จากโค้ด</a:t>
+                      </a:r>
+                    </a:p>
+                    <a:p>
+                      <a:r>
+                        <a:t>simulation</a:t>
+                      </a:r>
+                    </a:p>
+                  </a:txBody>
+                  <a:tcPr anchor="ctr" marL="54864" marR="54864" marT="18288" marB="18288">
+                    <a:solidFill>
+                      <a:srgbClr val="2D6A4F"/>
+                    </a:solidFill>
+                  </a:tcPr>
+                </a:tc>
+              </a:tr>
+              <a:tr h="508406">
+                <a:tc vMerge="1">
+                  <a:txBody>
+                    <a:bodyPr/>
+                    <a:lstStyle/>
+                    <a:p/>
+                  </a:txBody>
+                  <a:tcPr/>
+                </a:tc>
+                <a:tc>
+                  <a:txBody>
+                    <a:bodyPr/>
+                    <a:lstStyle/>
+                    <a:p>
+                      <a:pPr algn="ctr"/>
+                      <a:r>
+                        <a:rPr sz="1100" b="1">
+                          <a:solidFill>
+                            <a:srgbClr val="212529"/>
+                          </a:solidFill>
+                          <a:latin typeface="Arial"/>
+                        </a:rPr>
+                        <a:t>Bias²</a:t>
+                      </a:r>
+                    </a:p>
+                  </a:txBody>
+                  <a:tcPr anchor="ctr" marL="54864" marR="54864" marT="18288" marB="18288">
+                    <a:solidFill>
+                      <a:srgbClr val="F1F3F5"/>
                     </a:solidFill>
                   </a:tcPr>
                 </a:tc>
@@ -4727,19 +4828,19 @@
                     <a:p>
                       <a:pPr algn="ctr"/>
                       <a:r>
-                        <a:rPr sz="1500" b="1">
+                        <a:rPr sz="1100" b="1">
                           <a:solidFill>
-                            <a:srgbClr val="FFFFFF"/>
+                            <a:srgbClr val="212529"/>
                           </a:solidFill>
                           <a:latin typeface="Arial"/>
                         </a:rPr>
-                        <a:t>Bias²</a:t>
+                        <a:t>Variance</a:t>
                       </a:r>
                     </a:p>
                   </a:txBody>
-                  <a:tcPr anchor="ctr" marL="73152" marR="73152">
+                  <a:tcPr anchor="ctr" marL="54864" marR="54864" marT="18288" marB="18288">
                     <a:solidFill>
-                      <a:srgbClr val="2D6A4F"/>
+                      <a:srgbClr val="F1F3F5"/>
                     </a:solidFill>
                   </a:tcPr>
                 </a:tc>
@@ -4750,19 +4851,19 @@
                     <a:p>
                       <a:pPr algn="ctr"/>
                       <a:r>
-                        <a:rPr sz="1500" b="1">
+                        <a:rPr sz="1100" b="1">
                           <a:solidFill>
-                            <a:srgbClr val="FFFFFF"/>
+                            <a:srgbClr val="212529"/>
                           </a:solidFill>
                           <a:latin typeface="Arial"/>
                         </a:rPr>
-                        <a:t>Variance</a:t>
+                        <a:t>Eout (มือ)</a:t>
                       </a:r>
                     </a:p>
                   </a:txBody>
-                  <a:tcPr anchor="ctr" marL="73152" marR="73152">
+                  <a:tcPr anchor="ctr" marL="54864" marR="54864" marT="18288" marB="18288">
                     <a:solidFill>
-                      <a:srgbClr val="2D6A4F"/>
+                      <a:srgbClr val="F1F3F5"/>
                     </a:solidFill>
                   </a:tcPr>
                 </a:tc>
@@ -4773,24 +4874,24 @@
                     <a:p>
                       <a:pPr algn="ctr"/>
                       <a:r>
-                        <a:rPr sz="1500" b="1">
+                        <a:rPr sz="1100" b="1">
                           <a:solidFill>
-                            <a:srgbClr val="FFFFFF"/>
+                            <a:srgbClr val="212529"/>
                           </a:solidFill>
                           <a:latin typeface="Arial"/>
                         </a:rPr>
-                        <a:t>Eout</a:t>
+                        <a:t>Eout (โค้ด)</a:t>
                       </a:r>
                     </a:p>
                   </a:txBody>
-                  <a:tcPr anchor="ctr" marL="73152" marR="73152">
+                  <a:tcPr anchor="ctr" marL="54864" marR="54864" marT="18288" marB="18288">
                     <a:solidFill>
-                      <a:srgbClr val="2D6A4F"/>
+                      <a:srgbClr val="E8F5E9"/>
                     </a:solidFill>
                   </a:tcPr>
                 </a:tc>
               </a:tr>
-              <a:tr h="566928">
+              <a:tr h="508406">
                 <a:tc>
                   <a:txBody>
                     <a:bodyPr/>
@@ -4798,7 +4899,7 @@
                     <a:p>
                       <a:pPr algn="l"/>
                       <a:r>
-                        <a:rPr sz="1500" b="0">
+                        <a:rPr sz="1200" b="0">
                           <a:solidFill>
                             <a:srgbClr val="212529"/>
                           </a:solidFill>
@@ -4808,7 +4909,7 @@
                       </a:r>
                     </a:p>
                   </a:txBody>
-                  <a:tcPr anchor="ctr" marL="73152" marR="73152">
+                  <a:tcPr anchor="ctr" marL="54864" marR="54864" marT="18288" marB="18288">
                     <a:solidFill>
                       <a:srgbClr val="FFFFFF"/>
                     </a:solidFill>
@@ -4821,17 +4922,17 @@
                     <a:p>
                       <a:pPr algn="ctr"/>
                       <a:r>
-                        <a:rPr sz="1500" b="0">
+                        <a:rPr sz="1200" b="0">
                           <a:solidFill>
                             <a:srgbClr val="212529"/>
                           </a:solidFill>
                           <a:latin typeface="Arial"/>
                         </a:rPr>
-                        <a:t>0.4983</a:t>
+                        <a:t>0.5000</a:t>
                       </a:r>
                     </a:p>
                   </a:txBody>
-                  <a:tcPr anchor="ctr" marL="73152" marR="73152">
+                  <a:tcPr anchor="ctr" marL="54864" marR="54864" marT="18288" marB="18288">
                     <a:solidFill>
                       <a:srgbClr val="FFFFFF"/>
                     </a:solidFill>
@@ -4844,7 +4945,7 @@
                     <a:p>
                       <a:pPr algn="ctr"/>
                       <a:r>
-                        <a:rPr sz="1500" b="0">
+                        <a:rPr sz="1200" b="0">
                           <a:solidFill>
                             <a:srgbClr val="212529"/>
                           </a:solidFill>
@@ -4854,7 +4955,7 @@
                       </a:r>
                     </a:p>
                   </a:txBody>
-                  <a:tcPr anchor="ctr" marL="73152" marR="73152">
+                  <a:tcPr anchor="ctr" marL="54864" marR="54864" marT="18288" marB="18288">
                     <a:solidFill>
                       <a:srgbClr val="FFFFFF"/>
                     </a:solidFill>
@@ -4867,24 +4968,47 @@
                     <a:p>
                       <a:pPr algn="ctr"/>
                       <a:r>
-                        <a:rPr sz="1500" b="0">
+                        <a:rPr sz="1200" b="0">
                           <a:solidFill>
                             <a:srgbClr val="212529"/>
                           </a:solidFill>
                           <a:latin typeface="Arial"/>
                         </a:rPr>
-                        <a:t>0.7483</a:t>
+                        <a:t>0.7500</a:t>
                       </a:r>
                     </a:p>
                   </a:txBody>
-                  <a:tcPr anchor="ctr" marL="73152" marR="73152">
+                  <a:tcPr anchor="ctr" marL="54864" marR="54864" marT="18288" marB="18288">
                     <a:solidFill>
                       <a:srgbClr val="FFFFFF"/>
                     </a:solidFill>
                   </a:tcPr>
                 </a:tc>
+                <a:tc>
+                  <a:txBody>
+                    <a:bodyPr/>
+                    <a:lstStyle/>
+                    <a:p>
+                      <a:pPr algn="ctr"/>
+                      <a:r>
+                        <a:rPr sz="1200" b="0">
+                          <a:solidFill>
+                            <a:srgbClr val="212529"/>
+                          </a:solidFill>
+                          <a:latin typeface="Arial"/>
+                        </a:rPr>
+                        <a:t>0.7491</a:t>
+                      </a:r>
+                    </a:p>
+                  </a:txBody>
+                  <a:tcPr anchor="ctr" marL="54864" marR="54864" marT="18288" marB="18288">
+                    <a:solidFill>
+                      <a:srgbClr val="EDF7EF"/>
+                    </a:solidFill>
+                  </a:tcPr>
+                </a:tc>
               </a:tr>
-              <a:tr h="566928">
+              <a:tr h="508406">
                 <a:tc>
                   <a:txBody>
                     <a:bodyPr/>
@@ -4892,7 +5016,7 @@
                     <a:p>
                       <a:pPr algn="l"/>
                       <a:r>
-                        <a:rPr sz="1500" b="0">
+                        <a:rPr sz="1200" b="0">
                           <a:solidFill>
                             <a:srgbClr val="212529"/>
                           </a:solidFill>
@@ -4902,7 +5026,7 @@
                       </a:r>
                     </a:p>
                   </a:txBody>
-                  <a:tcPr anchor="ctr" marL="73152" marR="73152">
+                  <a:tcPr anchor="ctr" marL="54864" marR="54864" marT="18288" marB="18288">
                     <a:solidFill>
                       <a:srgbClr val="E9ECEF"/>
                     </a:solidFill>
@@ -4915,17 +5039,17 @@
                     <a:p>
                       <a:pPr algn="ctr"/>
                       <a:r>
-                        <a:rPr sz="1500" b="0">
+                        <a:rPr sz="1200" b="0">
                           <a:solidFill>
                             <a:srgbClr val="212529"/>
                           </a:solidFill>
                           <a:latin typeface="Arial"/>
                         </a:rPr>
-                        <a:t>0.2080</a:t>
+                        <a:t>0.2060</a:t>
                       </a:r>
                     </a:p>
                   </a:txBody>
-                  <a:tcPr anchor="ctr" marL="73152" marR="73152">
+                  <a:tcPr anchor="ctr" marL="54864" marR="54864" marT="18288" marB="18288">
                     <a:solidFill>
                       <a:srgbClr val="E9ECEF"/>
                     </a:solidFill>
@@ -4938,17 +5062,17 @@
                     <a:p>
                       <a:pPr algn="ctr"/>
                       <a:r>
-                        <a:rPr sz="1500" b="0">
+                        <a:rPr sz="1200" b="0">
                           <a:solidFill>
                             <a:srgbClr val="212529"/>
                           </a:solidFill>
                           <a:latin typeface="Arial"/>
                         </a:rPr>
-                        <a:t>1.6755</a:t>
+                        <a:t>1.6703</a:t>
                       </a:r>
                     </a:p>
                   </a:txBody>
-                  <a:tcPr anchor="ctr" marL="73152" marR="73152">
+                  <a:tcPr anchor="ctr" marL="54864" marR="54864" marT="18288" marB="18288">
                     <a:solidFill>
                       <a:srgbClr val="E9ECEF"/>
                     </a:solidFill>
@@ -4961,24 +5085,47 @@
                     <a:p>
                       <a:pPr algn="ctr"/>
                       <a:r>
-                        <a:rPr sz="1500" b="0">
+                        <a:rPr sz="1200" b="0">
                           <a:solidFill>
                             <a:srgbClr val="212529"/>
                           </a:solidFill>
                           <a:latin typeface="Arial"/>
                         </a:rPr>
-                        <a:t>1.8835</a:t>
+                        <a:t>1.8763</a:t>
                       </a:r>
                     </a:p>
                   </a:txBody>
-                  <a:tcPr anchor="ctr" marL="73152" marR="73152">
+                  <a:tcPr anchor="ctr" marL="54864" marR="54864" marT="18288" marB="18288">
                     <a:solidFill>
                       <a:srgbClr val="E9ECEF"/>
                     </a:solidFill>
                   </a:tcPr>
                 </a:tc>
+                <a:tc>
+                  <a:txBody>
+                    <a:bodyPr/>
+                    <a:lstStyle/>
+                    <a:p>
+                      <a:pPr algn="ctr"/>
+                      <a:r>
+                        <a:rPr sz="1200" b="0">
+                          <a:solidFill>
+                            <a:srgbClr val="212529"/>
+                          </a:solidFill>
+                          <a:latin typeface="Arial"/>
+                        </a:rPr>
+                        <a:t>1.8625</a:t>
+                      </a:r>
+                    </a:p>
+                  </a:txBody>
+                  <a:tcPr anchor="ctr" marL="54864" marR="54864" marT="18288" marB="18288">
+                    <a:solidFill>
+                      <a:srgbClr val="EDF7EF"/>
+                    </a:solidFill>
+                  </a:tcPr>
+                </a:tc>
               </a:tr>
-              <a:tr h="566928">
+              <a:tr h="508408">
                 <a:tc>
                   <a:txBody>
                     <a:bodyPr/>
@@ -4986,7 +5133,7 @@
                     <a:p>
                       <a:pPr algn="l"/>
                       <a:r>
-                        <a:rPr sz="1500" b="1">
+                        <a:rPr sz="1200" b="1">
                           <a:solidFill>
                             <a:srgbClr val="2D6A4F"/>
                           </a:solidFill>
@@ -4996,7 +5143,7 @@
                       </a:r>
                     </a:p>
                   </a:txBody>
-                  <a:tcPr anchor="ctr" marL="73152" marR="73152">
+                  <a:tcPr anchor="ctr" marL="54864" marR="54864" marT="18288" marB="18288">
                     <a:solidFill>
                       <a:srgbClr val="FFFFFF"/>
                     </a:solidFill>
@@ -5009,17 +5156,17 @@
                     <a:p>
                       <a:pPr algn="ctr"/>
                       <a:r>
-                        <a:rPr sz="1500" b="1">
+                        <a:rPr sz="1200" b="1">
                           <a:solidFill>
                             <a:srgbClr val="2D6A4F"/>
                           </a:solidFill>
                           <a:latin typeface="Arial"/>
                         </a:rPr>
-                        <a:t>0.2755</a:t>
+                        <a:t>0.2718</a:t>
                       </a:r>
                     </a:p>
                   </a:txBody>
-                  <a:tcPr anchor="ctr" marL="73152" marR="73152">
+                  <a:tcPr anchor="ctr" marL="54864" marR="54864" marT="18288" marB="18288">
                     <a:solidFill>
                       <a:srgbClr val="FFFFFF"/>
                     </a:solidFill>
@@ -5032,17 +5179,17 @@
                     <a:p>
                       <a:pPr algn="ctr"/>
                       <a:r>
-                        <a:rPr sz="1500" b="1">
+                        <a:rPr sz="1200" b="1">
                           <a:solidFill>
                             <a:srgbClr val="2D6A4F"/>
                           </a:solidFill>
                           <a:latin typeface="Arial"/>
                         </a:rPr>
-                        <a:t>0.2380</a:t>
+                        <a:t>0.2372</a:t>
                       </a:r>
                     </a:p>
                   </a:txBody>
-                  <a:tcPr anchor="ctr" marL="73152" marR="73152">
+                  <a:tcPr anchor="ctr" marL="54864" marR="54864" marT="18288" marB="18288">
                     <a:solidFill>
                       <a:srgbClr val="FFFFFF"/>
                     </a:solidFill>
@@ -5055,19 +5202,42 @@
                     <a:p>
                       <a:pPr algn="ctr"/>
                       <a:r>
-                        <a:rPr sz="1500" b="1">
+                        <a:rPr sz="1200" b="1">
                           <a:solidFill>
                             <a:srgbClr val="2D6A4F"/>
                           </a:solidFill>
                           <a:latin typeface="Arial"/>
                         </a:rPr>
-                        <a:t>0.5135</a:t>
+                        <a:t>0.5090</a:t>
                       </a:r>
                     </a:p>
                   </a:txBody>
-                  <a:tcPr anchor="ctr" marL="73152" marR="73152">
+                  <a:tcPr anchor="ctr" marL="54864" marR="54864" marT="18288" marB="18288">
                     <a:solidFill>
                       <a:srgbClr val="FFFFFF"/>
+                    </a:solidFill>
+                  </a:tcPr>
+                </a:tc>
+                <a:tc>
+                  <a:txBody>
+                    <a:bodyPr/>
+                    <a:lstStyle/>
+                    <a:p>
+                      <a:pPr algn="ctr"/>
+                      <a:r>
+                        <a:rPr sz="1200" b="1">
+                          <a:solidFill>
+                            <a:srgbClr val="2D6A4F"/>
+                          </a:solidFill>
+                          <a:latin typeface="Arial"/>
+                        </a:rPr>
+                        <a:t>0.5151</a:t>
+                      </a:r>
+                    </a:p>
+                  </a:txBody>
+                  <a:tcPr anchor="ctr" marL="54864" marR="54864" marT="18288" marB="18288">
+                    <a:solidFill>
+                      <a:srgbClr val="DFF2E3"/>
                     </a:solidFill>
                   </a:tcPr>
                 </a:tc>
@@ -5084,7 +5254,7 @@
         </p:nvSpPr>
         <p:spPr>
           <a:xfrm>
-            <a:off x="566928" y="4005072"/>
+            <a:off x="566928" y="4041648"/>
             <a:ext cx="2926080" cy="274320"/>
           </a:xfrm>
           <a:prstGeom prst="rect">
@@ -5213,13 +5383,13 @@
           <a:p>
             <a:pPr algn="l"/>
             <a:r>
-              <a:rPr sz="1100" b="0">
+              <a:rPr sz="1000" b="0">
                 <a:solidFill>
                   <a:srgbClr val="6C757D"/>
                 </a:solidFill>
                 <a:latin typeface="Arial"/>
               </a:rPr>
-              <a:t>สีเขียว = Eout ต่ำสุดในเป้าหมายนี้  |  Bias² ต่ำอย่างเดียวไม่พอ ถ้า Variance สูง Eout อาจแย่ลงได้</a:t>
+              <a:t>คำนวณมือ: จาก คำนวณมือ.pdf  |  โค้ด: simulation จาก results.json  |  สีเขียวอ่อน = Eout จากโค้ดต่ำสุด</a:t>
             </a:r>
           </a:p>
         </p:txBody>
@@ -5486,7 +5656,7 @@
         </p:nvGraphicFramePr>
         <p:xfrm>
           <a:off x="566928" y="1444752"/>
-          <a:ext cx="11045952" cy="2267712"/>
+          <a:ext cx="11045951" cy="2542032"/>
         </p:xfrm>
         <a:graphic>
           <a:graphicData uri="http://schemas.openxmlformats.org/drawingml/2006/table">
@@ -5495,20 +5665,21 @@
                 <a:tableStyleId>{5C22544A-7EE6-4342-B048-85BDC9FD1C3A}</a:tableStyleId>
               </a:tblPr>
               <a:tblGrid>
-                <a:gridCol w="3246120"/>
-                <a:gridCol w="2560320"/>
-                <a:gridCol w="2743200"/>
+                <a:gridCol w="2514600"/>
+                <a:gridCol w="1874519"/>
+                <a:gridCol w="1920240"/>
+                <a:gridCol w="2240280"/>
                 <a:gridCol w="2496312"/>
               </a:tblGrid>
-              <a:tr h="566928">
-                <a:tc>
+              <a:tr h="508406">
+                <a:tc rowSpan="2">
                   <a:txBody>
                     <a:bodyPr/>
                     <a:lstStyle/>
                     <a:p>
                       <a:pPr algn="l"/>
                       <a:r>
-                        <a:rPr sz="1500" b="1">
+                        <a:rPr sz="1200" b="1">
                           <a:solidFill>
                             <a:srgbClr val="FFFFFF"/>
                           </a:solidFill>
@@ -5518,9 +5689,109 @@
                       </a:r>
                     </a:p>
                   </a:txBody>
-                  <a:tcPr anchor="ctr" marL="73152" marR="73152">
+                  <a:tcPr anchor="ctr" marL="54864" marR="54864" marT="18288" marB="18288">
                     <a:solidFill>
                       <a:srgbClr val="2D6A4F"/>
+                    </a:solidFill>
+                  </a:tcPr>
+                </a:tc>
+                <a:tc gridSpan="3">
+                  <a:txBody>
+                    <a:bodyPr/>
+                    <a:lstStyle/>
+                    <a:p>
+                      <a:pPr algn="ctr"/>
+                      <a:r>
+                        <a:rPr sz="1200" b="1">
+                          <a:solidFill>
+                            <a:srgbClr val="FFFFFF"/>
+                          </a:solidFill>
+                          <a:latin typeface="Arial"/>
+                        </a:rPr>
+                        <a:t>คำนวณมือ</a:t>
+                      </a:r>
+                    </a:p>
+                  </a:txBody>
+                  <a:tcPr anchor="ctr" marL="54864" marR="54864" marT="18288" marB="18288">
+                    <a:solidFill>
+                      <a:srgbClr val="6C757D"/>
+                    </a:solidFill>
+                  </a:tcPr>
+                </a:tc>
+                <a:tc hMerge="1">
+                  <a:txBody>
+                    <a:bodyPr/>
+                    <a:lstStyle/>
+                    <a:p/>
+                  </a:txBody>
+                  <a:tcPr/>
+                </a:tc>
+                <a:tc hMerge="1">
+                  <a:txBody>
+                    <a:bodyPr/>
+                    <a:lstStyle/>
+                    <a:p/>
+                  </a:txBody>
+                  <a:tcPr/>
+                </a:tc>
+                <a:tc>
+                  <a:txBody>
+                    <a:bodyPr/>
+                    <a:lstStyle/>
+                    <a:p>
+                      <a:pPr algn="ctr"/>
+                      <a:r>
+                        <a:rPr sz="1200" b="1">
+                          <a:solidFill>
+                            <a:srgbClr val="FFFFFF"/>
+                          </a:solidFill>
+                          <a:latin typeface="Arial"/>
+                        </a:rPr>
+                        <a:t>จากโค้ด</a:t>
+                      </a:r>
+                    </a:p>
+                    <a:p>
+                      <a:r>
+                        <a:t>simulation</a:t>
+                      </a:r>
+                    </a:p>
+                  </a:txBody>
+                  <a:tcPr anchor="ctr" marL="54864" marR="54864" marT="18288" marB="18288">
+                    <a:solidFill>
+                      <a:srgbClr val="2D6A4F"/>
+                    </a:solidFill>
+                  </a:tcPr>
+                </a:tc>
+              </a:tr>
+              <a:tr h="508406">
+                <a:tc vMerge="1">
+                  <a:txBody>
+                    <a:bodyPr/>
+                    <a:lstStyle/>
+                    <a:p/>
+                  </a:txBody>
+                  <a:tcPr/>
+                </a:tc>
+                <a:tc>
+                  <a:txBody>
+                    <a:bodyPr/>
+                    <a:lstStyle/>
+                    <a:p>
+                      <a:pPr algn="ctr"/>
+                      <a:r>
+                        <a:rPr sz="1100" b="1">
+                          <a:solidFill>
+                            <a:srgbClr val="212529"/>
+                          </a:solidFill>
+                          <a:latin typeface="Arial"/>
+                        </a:rPr>
+                        <a:t>Bias²</a:t>
+                      </a:r>
+                    </a:p>
+                  </a:txBody>
+                  <a:tcPr anchor="ctr" marL="54864" marR="54864" marT="18288" marB="18288">
+                    <a:solidFill>
+                      <a:srgbClr val="F1F3F5"/>
                     </a:solidFill>
                   </a:tcPr>
                 </a:tc>
@@ -5531,19 +5802,19 @@
                     <a:p>
                       <a:pPr algn="ctr"/>
                       <a:r>
-                        <a:rPr sz="1500" b="1">
+                        <a:rPr sz="1100" b="1">
                           <a:solidFill>
-                            <a:srgbClr val="FFFFFF"/>
+                            <a:srgbClr val="212529"/>
                           </a:solidFill>
                           <a:latin typeface="Arial"/>
                         </a:rPr>
-                        <a:t>Bias²</a:t>
+                        <a:t>Variance</a:t>
                       </a:r>
                     </a:p>
                   </a:txBody>
-                  <a:tcPr anchor="ctr" marL="73152" marR="73152">
+                  <a:tcPr anchor="ctr" marL="54864" marR="54864" marT="18288" marB="18288">
                     <a:solidFill>
-                      <a:srgbClr val="2D6A4F"/>
+                      <a:srgbClr val="F1F3F5"/>
                     </a:solidFill>
                   </a:tcPr>
                 </a:tc>
@@ -5554,19 +5825,19 @@
                     <a:p>
                       <a:pPr algn="ctr"/>
                       <a:r>
-                        <a:rPr sz="1500" b="1">
+                        <a:rPr sz="1100" b="1">
                           <a:solidFill>
-                            <a:srgbClr val="FFFFFF"/>
+                            <a:srgbClr val="212529"/>
                           </a:solidFill>
                           <a:latin typeface="Arial"/>
                         </a:rPr>
-                        <a:t>Variance</a:t>
+                        <a:t>Eout (มือ)</a:t>
                       </a:r>
                     </a:p>
                   </a:txBody>
-                  <a:tcPr anchor="ctr" marL="73152" marR="73152">
+                  <a:tcPr anchor="ctr" marL="54864" marR="54864" marT="18288" marB="18288">
                     <a:solidFill>
-                      <a:srgbClr val="2D6A4F"/>
+                      <a:srgbClr val="F1F3F5"/>
                     </a:solidFill>
                   </a:tcPr>
                 </a:tc>
@@ -5577,24 +5848,24 @@
                     <a:p>
                       <a:pPr algn="ctr"/>
                       <a:r>
-                        <a:rPr sz="1500" b="1">
+                        <a:rPr sz="1100" b="1">
                           <a:solidFill>
-                            <a:srgbClr val="FFFFFF"/>
+                            <a:srgbClr val="212529"/>
                           </a:solidFill>
                           <a:latin typeface="Arial"/>
                         </a:rPr>
-                        <a:t>Eout</a:t>
+                        <a:t>Eout (โค้ด)</a:t>
                       </a:r>
                     </a:p>
                   </a:txBody>
-                  <a:tcPr anchor="ctr" marL="73152" marR="73152">
+                  <a:tcPr anchor="ctr" marL="54864" marR="54864" marT="18288" marB="18288">
                     <a:solidFill>
-                      <a:srgbClr val="2D6A4F"/>
+                      <a:srgbClr val="E8F5E9"/>
                     </a:solidFill>
                   </a:tcPr>
                 </a:tc>
               </a:tr>
-              <a:tr h="566928">
+              <a:tr h="508406">
                 <a:tc>
                   <a:txBody>
                     <a:bodyPr/>
@@ -5602,7 +5873,7 @@
                     <a:p>
                       <a:pPr algn="l"/>
                       <a:r>
-                        <a:rPr sz="1500" b="1">
+                        <a:rPr sz="1200" b="1">
                           <a:solidFill>
                             <a:srgbClr val="2D6A4F"/>
                           </a:solidFill>
@@ -5612,7 +5883,7 @@
                       </a:r>
                     </a:p>
                   </a:txBody>
-                  <a:tcPr anchor="ctr" marL="73152" marR="73152">
+                  <a:tcPr anchor="ctr" marL="54864" marR="54864" marT="18288" marB="18288">
                     <a:solidFill>
                       <a:srgbClr val="FFFFFF"/>
                     </a:solidFill>
@@ -5625,17 +5896,17 @@
                     <a:p>
                       <a:pPr algn="ctr"/>
                       <a:r>
-                        <a:rPr sz="1500" b="1">
+                        <a:rPr sz="1200" b="1">
                           <a:solidFill>
                             <a:srgbClr val="2D6A4F"/>
                           </a:solidFill>
                           <a:latin typeface="Arial"/>
                         </a:rPr>
-                        <a:t>0.0901</a:t>
+                        <a:t>0.0889</a:t>
                       </a:r>
                     </a:p>
                   </a:txBody>
-                  <a:tcPr anchor="ctr" marL="73152" marR="73152">
+                  <a:tcPr anchor="ctr" marL="54864" marR="54864" marT="18288" marB="18288">
                     <a:solidFill>
                       <a:srgbClr val="FFFFFF"/>
                     </a:solidFill>
@@ -5648,17 +5919,17 @@
                     <a:p>
                       <a:pPr algn="ctr"/>
                       <a:r>
-                        <a:rPr sz="1500" b="1">
+                        <a:rPr sz="1200" b="1">
                           <a:solidFill>
                             <a:srgbClr val="2D6A4F"/>
                           </a:solidFill>
                           <a:latin typeface="Arial"/>
                         </a:rPr>
-                        <a:t>0.0445</a:t>
+                        <a:t>0.0444</a:t>
                       </a:r>
                     </a:p>
                   </a:txBody>
-                  <a:tcPr anchor="ctr" marL="73152" marR="73152">
+                  <a:tcPr anchor="ctr" marL="54864" marR="54864" marT="18288" marB="18288">
                     <a:solidFill>
                       <a:srgbClr val="FFFFFF"/>
                     </a:solidFill>
@@ -5671,7 +5942,30 @@
                     <a:p>
                       <a:pPr algn="ctr"/>
                       <a:r>
-                        <a:rPr sz="1500" b="1">
+                        <a:rPr sz="1200" b="1">
+                          <a:solidFill>
+                            <a:srgbClr val="2D6A4F"/>
+                          </a:solidFill>
+                          <a:latin typeface="Arial"/>
+                        </a:rPr>
+                        <a:t>0.1333</a:t>
+                      </a:r>
+                    </a:p>
+                  </a:txBody>
+                  <a:tcPr anchor="ctr" marL="54864" marR="54864" marT="18288" marB="18288">
+                    <a:solidFill>
+                      <a:srgbClr val="FFFFFF"/>
+                    </a:solidFill>
+                  </a:tcPr>
+                </a:tc>
+                <a:tc>
+                  <a:txBody>
+                    <a:bodyPr/>
+                    <a:lstStyle/>
+                    <a:p>
+                      <a:pPr algn="ctr"/>
+                      <a:r>
+                        <a:rPr sz="1200" b="1">
                           <a:solidFill>
                             <a:srgbClr val="2D6A4F"/>
                           </a:solidFill>
@@ -5681,14 +5975,14 @@
                       </a:r>
                     </a:p>
                   </a:txBody>
-                  <a:tcPr anchor="ctr" marL="73152" marR="73152">
+                  <a:tcPr anchor="ctr" marL="54864" marR="54864" marT="18288" marB="18288">
                     <a:solidFill>
-                      <a:srgbClr val="FFFFFF"/>
+                      <a:srgbClr val="DFF2E3"/>
                     </a:solidFill>
                   </a:tcPr>
                 </a:tc>
               </a:tr>
-              <a:tr h="566928">
+              <a:tr h="508406">
                 <a:tc>
                   <a:txBody>
                     <a:bodyPr/>
@@ -5696,7 +5990,7 @@
                     <a:p>
                       <a:pPr algn="l"/>
                       <a:r>
-                        <a:rPr sz="1500" b="0">
+                        <a:rPr sz="1200" b="0">
                           <a:solidFill>
                             <a:srgbClr val="212529"/>
                           </a:solidFill>
@@ -5706,7 +6000,7 @@
                       </a:r>
                     </a:p>
                   </a:txBody>
-                  <a:tcPr anchor="ctr" marL="73152" marR="73152">
+                  <a:tcPr anchor="ctr" marL="54864" marR="54864" marT="18288" marB="18288">
                     <a:solidFill>
                       <a:srgbClr val="E9ECEF"/>
                     </a:solidFill>
@@ -5719,17 +6013,17 @@
                     <a:p>
                       <a:pPr algn="ctr"/>
                       <a:r>
-                        <a:rPr sz="1500" b="0">
+                        <a:rPr sz="1200" b="0">
                           <a:solidFill>
                             <a:srgbClr val="212529"/>
                           </a:solidFill>
                           <a:latin typeface="Arial"/>
                         </a:rPr>
-                        <a:t>0.2017</a:t>
+                        <a:t>0.2000</a:t>
                       </a:r>
                     </a:p>
                   </a:txBody>
-                  <a:tcPr anchor="ctr" marL="73152" marR="73152">
+                  <a:tcPr anchor="ctr" marL="54864" marR="54864" marT="18288" marB="18288">
                     <a:solidFill>
                       <a:srgbClr val="E9ECEF"/>
                     </a:solidFill>
@@ -5742,17 +6036,17 @@
                     <a:p>
                       <a:pPr algn="ctr"/>
                       <a:r>
-                        <a:rPr sz="1500" b="0">
+                        <a:rPr sz="1200" b="0">
                           <a:solidFill>
                             <a:srgbClr val="212529"/>
                           </a:solidFill>
                           <a:latin typeface="Arial"/>
                         </a:rPr>
-                        <a:t>0.3324</a:t>
+                        <a:t>0.3333</a:t>
                       </a:r>
                     </a:p>
                   </a:txBody>
-                  <a:tcPr anchor="ctr" marL="73152" marR="73152">
+                  <a:tcPr anchor="ctr" marL="54864" marR="54864" marT="18288" marB="18288">
                     <a:solidFill>
                       <a:srgbClr val="E9ECEF"/>
                     </a:solidFill>
@@ -5765,24 +6059,47 @@
                     <a:p>
                       <a:pPr algn="ctr"/>
                       <a:r>
-                        <a:rPr sz="1500" b="0">
+                        <a:rPr sz="1200" b="0">
                           <a:solidFill>
                             <a:srgbClr val="212529"/>
                           </a:solidFill>
                           <a:latin typeface="Arial"/>
                         </a:rPr>
-                        <a:t>0.5342</a:t>
+                        <a:t>0.5333</a:t>
                       </a:r>
                     </a:p>
                   </a:txBody>
-                  <a:tcPr anchor="ctr" marL="73152" marR="73152">
+                  <a:tcPr anchor="ctr" marL="54864" marR="54864" marT="18288" marB="18288">
                     <a:solidFill>
                       <a:srgbClr val="E9ECEF"/>
                     </a:solidFill>
                   </a:tcPr>
                 </a:tc>
+                <a:tc>
+                  <a:txBody>
+                    <a:bodyPr/>
+                    <a:lstStyle/>
+                    <a:p>
+                      <a:pPr algn="ctr"/>
+                      <a:r>
+                        <a:rPr sz="1200" b="0">
+                          <a:solidFill>
+                            <a:srgbClr val="212529"/>
+                          </a:solidFill>
+                          <a:latin typeface="Arial"/>
+                        </a:rPr>
+                        <a:t>0.5414</a:t>
+                      </a:r>
+                    </a:p>
+                  </a:txBody>
+                  <a:tcPr anchor="ctr" marL="54864" marR="54864" marT="18288" marB="18288">
+                    <a:solidFill>
+                      <a:srgbClr val="EDF7EF"/>
+                    </a:solidFill>
+                  </a:tcPr>
+                </a:tc>
               </a:tr>
-              <a:tr h="566928">
+              <a:tr h="508408">
                 <a:tc>
                   <a:txBody>
                     <a:bodyPr/>
@@ -5790,7 +6107,7 @@
                     <a:p>
                       <a:pPr algn="l"/>
                       <a:r>
-                        <a:rPr sz="1500" b="0">
+                        <a:rPr sz="1200" b="0">
                           <a:solidFill>
                             <a:srgbClr val="212529"/>
                           </a:solidFill>
@@ -5800,7 +6117,7 @@
                       </a:r>
                     </a:p>
                   </a:txBody>
-                  <a:tcPr anchor="ctr" marL="73152" marR="73152">
+                  <a:tcPr anchor="ctr" marL="54864" marR="54864" marT="18288" marB="18288">
                     <a:solidFill>
                       <a:srgbClr val="FFFFFF"/>
                     </a:solidFill>
@@ -5813,17 +6130,17 @@
                     <a:p>
                       <a:pPr algn="ctr"/>
                       <a:r>
-                        <a:rPr sz="1500" b="0">
+                        <a:rPr sz="1200" b="0">
                           <a:solidFill>
                             <a:srgbClr val="212529"/>
                           </a:solidFill>
                           <a:latin typeface="Arial"/>
                         </a:rPr>
-                        <a:t>0.2027</a:t>
+                        <a:t>0.2000</a:t>
                       </a:r>
                     </a:p>
                   </a:txBody>
-                  <a:tcPr anchor="ctr" marL="73152" marR="73152">
+                  <a:tcPr anchor="ctr" marL="54864" marR="54864" marT="18288" marB="18288">
                     <a:solidFill>
                       <a:srgbClr val="FFFFFF"/>
                     </a:solidFill>
@@ -5836,17 +6153,17 @@
                     <a:p>
                       <a:pPr algn="ctr"/>
                       <a:r>
-                        <a:rPr sz="1500" b="0">
+                        <a:rPr sz="1200" b="0">
                           <a:solidFill>
                             <a:srgbClr val="212529"/>
                           </a:solidFill>
                           <a:latin typeface="Arial"/>
                         </a:rPr>
-                        <a:t>0.1158</a:t>
+                        <a:t>0.1147</a:t>
                       </a:r>
                     </a:p>
                   </a:txBody>
-                  <a:tcPr anchor="ctr" marL="73152" marR="73152">
+                  <a:tcPr anchor="ctr" marL="54864" marR="54864" marT="18288" marB="18288">
                     <a:solidFill>
                       <a:srgbClr val="FFFFFF"/>
                     </a:solidFill>
@@ -5859,19 +6176,42 @@
                     <a:p>
                       <a:pPr algn="ctr"/>
                       <a:r>
-                        <a:rPr sz="1500" b="0">
+                        <a:rPr sz="1200" b="0">
                           <a:solidFill>
                             <a:srgbClr val="212529"/>
                           </a:solidFill>
                           <a:latin typeface="Arial"/>
                         </a:rPr>
-                        <a:t>0.3185</a:t>
+                        <a:t>0.3147</a:t>
                       </a:r>
                     </a:p>
                   </a:txBody>
-                  <a:tcPr anchor="ctr" marL="73152" marR="73152">
+                  <a:tcPr anchor="ctr" marL="54864" marR="54864" marT="18288" marB="18288">
                     <a:solidFill>
                       <a:srgbClr val="FFFFFF"/>
+                    </a:solidFill>
+                  </a:tcPr>
+                </a:tc>
+                <a:tc>
+                  <a:txBody>
+                    <a:bodyPr/>
+                    <a:lstStyle/>
+                    <a:p>
+                      <a:pPr algn="ctr"/>
+                      <a:r>
+                        <a:rPr sz="1200" b="0">
+                          <a:solidFill>
+                            <a:srgbClr val="212529"/>
+                          </a:solidFill>
+                          <a:latin typeface="Arial"/>
+                        </a:rPr>
+                        <a:t>0.3182</a:t>
+                      </a:r>
+                    </a:p>
+                  </a:txBody>
+                  <a:tcPr anchor="ctr" marL="54864" marR="54864" marT="18288" marB="18288">
+                    <a:solidFill>
+                      <a:srgbClr val="EDF7EF"/>
                     </a:solidFill>
                   </a:tcPr>
                 </a:tc>
@@ -5888,7 +6228,7 @@
         </p:nvSpPr>
         <p:spPr>
           <a:xfrm>
-            <a:off x="566928" y="4005072"/>
+            <a:off x="566928" y="4041648"/>
             <a:ext cx="2926080" cy="274320"/>
           </a:xfrm>
           <a:prstGeom prst="rect">
@@ -6017,13 +6357,13 @@
           <a:p>
             <a:pPr algn="l"/>
             <a:r>
-              <a:rPr sz="1100" b="0">
+              <a:rPr sz="1000" b="0">
                 <a:solidFill>
                   <a:srgbClr val="6C757D"/>
                 </a:solidFill>
                 <a:latin typeface="Arial"/>
               </a:rPr>
-              <a:t>สีเขียว = Eout ต่ำสุดในเป้าหมายนี้  |  Bias² ต่ำอย่างเดียวไม่พอ ถ้า Variance สูง Eout อาจแย่ลงได้</a:t>
+              <a:t>คำนวณมือ: จาก คำนวณมือ.pdf  |  โค้ด: simulation จาก results.json  |  สีเขียวอ่อน = Eout จากโค้ดต่ำสุด</a:t>
             </a:r>
           </a:p>
         </p:txBody>

</xml_diff>

<commit_message>
feat: add new experiment datasets and update assignment scripts and visuals
</commit_message>
<xml_diff>
--- a/Assignment/Week3/Slide/slides_Week3.pptx
+++ b/Assignment/Week3/Slide/slides_Week3.pptx
@@ -3716,7 +3716,7 @@
       </p:sp>
       <p:sp>
         <p:nvSpPr>
-          <p:cNvPr id="7" name="Rounded Rectangle 6"/>
+          <p:cNvPr id="7" name="Rectangle 6"/>
           <p:cNvSpPr/>
           <p:nvPr/>
         </p:nvSpPr>
@@ -3725,7 +3725,7 @@
             <a:off x="685800" y="1325880"/>
             <a:ext cx="10835640" cy="804672"/>
           </a:xfrm>
-          <a:prstGeom prst="roundRect">
+          <a:prstGeom prst="rect">
             <a:avLst/>
           </a:prstGeom>
           <a:solidFill>
@@ -3835,6 +3835,141 @@
         </p:nvSpPr>
         <p:spPr>
           <a:xfrm>
+            <a:off x="685800" y="2834640"/>
+            <a:ext cx="3401568" cy="2084831"/>
+          </a:xfrm>
+          <a:prstGeom prst="rect">
+            <a:avLst/>
+          </a:prstGeom>
+          <a:solidFill>
+            <a:srgbClr val="FFFFFF"/>
+          </a:solidFill>
+          <a:ln w="54864">
+            <a:solidFill>
+              <a:srgbClr val="DEE2E6"/>
+            </a:solidFill>
+          </a:ln>
+        </p:spPr>
+        <p:style>
+          <a:lnRef idx="1">
+            <a:schemeClr val="accent1"/>
+          </a:lnRef>
+          <a:fillRef idx="3">
+            <a:schemeClr val="accent1"/>
+          </a:fillRef>
+          <a:effectRef idx="2">
+            <a:schemeClr val="accent1"/>
+          </a:effectRef>
+          <a:fontRef idx="minor">
+            <a:schemeClr val="lt1"/>
+          </a:fontRef>
+        </p:style>
+        <p:txBody>
+          <a:bodyPr rtlCol="0" anchor="ctr"/>
+          <a:lstStyle/>
+          <a:p>
+            <a:pPr algn="ctr"/>
+          </a:p>
+        </p:txBody>
+      </p:sp>
+      <p:sp>
+        <p:nvSpPr>
+          <p:cNvPr id="11" name="Rectangle 10"/>
+          <p:cNvSpPr/>
+          <p:nvPr/>
+        </p:nvSpPr>
+        <p:spPr>
+          <a:xfrm>
+            <a:off x="4370832" y="2834640"/>
+            <a:ext cx="3401568" cy="2084831"/>
+          </a:xfrm>
+          <a:prstGeom prst="rect">
+            <a:avLst/>
+          </a:prstGeom>
+          <a:solidFill>
+            <a:srgbClr val="FFFFFF"/>
+          </a:solidFill>
+          <a:ln w="54864">
+            <a:solidFill>
+              <a:srgbClr val="DEE2E6"/>
+            </a:solidFill>
+          </a:ln>
+        </p:spPr>
+        <p:style>
+          <a:lnRef idx="1">
+            <a:schemeClr val="accent1"/>
+          </a:lnRef>
+          <a:fillRef idx="3">
+            <a:schemeClr val="accent1"/>
+          </a:fillRef>
+          <a:effectRef idx="2">
+            <a:schemeClr val="accent1"/>
+          </a:effectRef>
+          <a:fontRef idx="minor">
+            <a:schemeClr val="lt1"/>
+          </a:fontRef>
+        </p:style>
+        <p:txBody>
+          <a:bodyPr rtlCol="0" anchor="ctr"/>
+          <a:lstStyle/>
+          <a:p>
+            <a:pPr algn="ctr"/>
+          </a:p>
+        </p:txBody>
+      </p:sp>
+      <p:sp>
+        <p:nvSpPr>
+          <p:cNvPr id="12" name="Rectangle 11"/>
+          <p:cNvSpPr/>
+          <p:nvPr/>
+        </p:nvSpPr>
+        <p:spPr>
+          <a:xfrm>
+            <a:off x="8055864" y="2834640"/>
+            <a:ext cx="3456432" cy="2084831"/>
+          </a:xfrm>
+          <a:prstGeom prst="rect">
+            <a:avLst/>
+          </a:prstGeom>
+          <a:solidFill>
+            <a:srgbClr val="FFFFFF"/>
+          </a:solidFill>
+          <a:ln w="54864">
+            <a:solidFill>
+              <a:srgbClr val="DEE2E6"/>
+            </a:solidFill>
+          </a:ln>
+        </p:spPr>
+        <p:style>
+          <a:lnRef idx="1">
+            <a:schemeClr val="accent1"/>
+          </a:lnRef>
+          <a:fillRef idx="3">
+            <a:schemeClr val="accent1"/>
+          </a:fillRef>
+          <a:effectRef idx="2">
+            <a:schemeClr val="accent1"/>
+          </a:effectRef>
+          <a:fontRef idx="minor">
+            <a:schemeClr val="lt1"/>
+          </a:fontRef>
+        </p:style>
+        <p:txBody>
+          <a:bodyPr rtlCol="0" anchor="ctr"/>
+          <a:lstStyle/>
+          <a:p>
+            <a:pPr algn="ctr"/>
+          </a:p>
+        </p:txBody>
+      </p:sp>
+      <p:sp>
+        <p:nvSpPr>
+          <p:cNvPr id="13" name="Rectangle 12"/>
+          <p:cNvSpPr/>
+          <p:nvPr/>
+        </p:nvSpPr>
+        <p:spPr>
+          <a:xfrm>
             <a:off x="685800" y="2926080"/>
             <a:ext cx="54864" cy="1920240"/>
           </a:xfrm>
@@ -3872,7 +4007,7 @@
       </p:sp>
       <p:sp>
         <p:nvSpPr>
-          <p:cNvPr id="11" name="TextBox 10"/>
+          <p:cNvPr id="14" name="TextBox 13"/>
           <p:cNvSpPr txBox="1"/>
           <p:nvPr/>
         </p:nvSpPr>
@@ -3907,7 +4042,7 @@
       </p:sp>
       <p:sp>
         <p:nvSpPr>
-          <p:cNvPr id="12" name="TextBox 11"/>
+          <p:cNvPr id="15" name="TextBox 14"/>
           <p:cNvSpPr txBox="1"/>
           <p:nvPr/>
         </p:nvSpPr>
@@ -3963,7 +4098,7 @@
       </p:sp>
       <p:sp>
         <p:nvSpPr>
-          <p:cNvPr id="13" name="Rectangle 12"/>
+          <p:cNvPr id="16" name="Rectangle 15"/>
           <p:cNvSpPr/>
           <p:nvPr/>
         </p:nvSpPr>
@@ -4006,7 +4141,7 @@
       </p:sp>
       <p:sp>
         <p:nvSpPr>
-          <p:cNvPr id="14" name="TextBox 13"/>
+          <p:cNvPr id="17" name="TextBox 16"/>
           <p:cNvSpPr txBox="1"/>
           <p:nvPr/>
         </p:nvSpPr>
@@ -4041,7 +4176,7 @@
       </p:sp>
       <p:sp>
         <p:nvSpPr>
-          <p:cNvPr id="15" name="TextBox 14"/>
+          <p:cNvPr id="18" name="TextBox 17"/>
           <p:cNvSpPr txBox="1"/>
           <p:nvPr/>
         </p:nvSpPr>
@@ -4097,7 +4232,7 @@
       </p:sp>
       <p:sp>
         <p:nvSpPr>
-          <p:cNvPr id="16" name="Rectangle 15"/>
+          <p:cNvPr id="19" name="Rectangle 18"/>
           <p:cNvSpPr/>
           <p:nvPr/>
         </p:nvSpPr>
@@ -4140,7 +4275,7 @@
       </p:sp>
       <p:sp>
         <p:nvSpPr>
-          <p:cNvPr id="17" name="TextBox 16"/>
+          <p:cNvPr id="20" name="TextBox 19"/>
           <p:cNvSpPr txBox="1"/>
           <p:nvPr/>
         </p:nvSpPr>
@@ -4175,7 +4310,7 @@
       </p:sp>
       <p:sp>
         <p:nvSpPr>
-          <p:cNvPr id="18" name="TextBox 17"/>
+          <p:cNvPr id="21" name="TextBox 20"/>
           <p:cNvSpPr txBox="1"/>
           <p:nvPr/>
         </p:nvSpPr>
@@ -4231,7 +4366,7 @@
       </p:sp>
       <p:sp>
         <p:nvSpPr>
-          <p:cNvPr id="19" name="Rounded Rectangle 18"/>
+          <p:cNvPr id="22" name="Rectangle 21"/>
           <p:cNvSpPr/>
           <p:nvPr/>
         </p:nvSpPr>
@@ -4240,7 +4375,7 @@
             <a:off x="1234440" y="5230368"/>
             <a:ext cx="9738360" cy="658368"/>
           </a:xfrm>
-          <a:prstGeom prst="roundRect">
+          <a:prstGeom prst="rect">
             <a:avLst/>
           </a:prstGeom>
           <a:solidFill>
@@ -4274,7 +4409,7 @@
       </p:sp>
       <p:sp>
         <p:nvSpPr>
-          <p:cNvPr id="20" name="TextBox 19"/>
+          <p:cNvPr id="23" name="TextBox 22"/>
           <p:cNvSpPr txBox="1"/>
           <p:nvPr/>
         </p:nvSpPr>
@@ -4309,7 +4444,7 @@
       </p:sp>
       <p:sp>
         <p:nvSpPr>
-          <p:cNvPr id="21" name="Rectangle 20"/>
+          <p:cNvPr id="24" name="Rectangle 23"/>
           <p:cNvSpPr/>
           <p:nvPr/>
         </p:nvSpPr>
@@ -4352,7 +4487,7 @@
       </p:sp>
       <p:sp>
         <p:nvSpPr>
-          <p:cNvPr id="22" name="TextBox 21"/>
+          <p:cNvPr id="25" name="TextBox 24"/>
           <p:cNvSpPr txBox="1"/>
           <p:nvPr/>
         </p:nvSpPr>
@@ -4387,7 +4522,7 @@
       </p:sp>
       <p:sp>
         <p:nvSpPr>
-          <p:cNvPr id="23" name="TextBox 22"/>
+          <p:cNvPr id="26" name="TextBox 25"/>
           <p:cNvSpPr txBox="1"/>
           <p:nvPr/>
         </p:nvSpPr>

</xml_diff>